<commit_message>
Update thresholds in tests and documentation; add script for LaTeX to plain text conversion
- Changed KNN threshold from 0.65 to 0.85 in test documentation and unit tests to reflect updated values.
- Introduced a new script `paper_text.py` for converting LaTeX documents to plain text and vice versa, allowing for easier editing of specific sections while preserving the original structure.
</commit_message>
<xml_diff>
--- a/docs/Phase III/ECHO_Phase3_Review3.pptx
+++ b/docs/Phase III/ECHO_Phase3_Review3.pptx
@@ -269,7 +269,7 @@
               <a:pPr>
                 <a:defRPr/>
               </a:pPr>
-              <a:t>10/22/2026</a:t>
+              <a:t>10/26/2026</a:t>
             </a:fld>
             <a:endParaRPr lang="en-US"/>
           </a:p>
@@ -452,7 +452,7 @@
               <a:pPr>
                 <a:defRPr/>
               </a:pPr>
-              <a:t>10/22/2026</a:t>
+              <a:t>10/26/2026</a:t>
             </a:fld>
             <a:endParaRPr lang="en-US"/>
           </a:p>
@@ -871,7 +871,7 @@
           <a:lstStyle/>
           <a:p>
             <a:r>
-              <a:t>~45 s. The example question is traced from the design; it is not a recorded run, and the chat on the right is an illustration of the answer format, not a screenshot. Answers are short chat replies; each citation becomes a memory pill (source logo, sender or site, date). Solid = the item says it, dashed = related context. Clicking a pill opens the original mail or page. Live progress ('Searching Gmail...') streams while it works. Follow-ups: each chat has its own session, so the next question continues from the earlier turns. Attachment questions send the best three matching passages (about 1,500 characters). The MCP server lets Claude Desktop call the same read-only tools: search_memories, get_memory, recent_activity.</a:t>
+              <a:t>~45 s. The example question is traced from the design; it is not a recorded run, and the chat on the right is an illustration of the answer format, not a screenshot. Answers are short chat replies; each citation becomes a memory pill (source logo, sender or site, date). Solid = the item says it, dashed = related context. Clicking a pill opens the original mail or page. Live progress ('Searching Gmail...') streams while it works. Follow-ups: each chat has its own session, so the next question continues from the earlier turns. An attachment question adds the attachment text (up to 40,000 characters). The MCP server lets Claude Desktop call the same read-only tools: search_memories, get_memory, recent_activity.</a:t>
             </a:r>
           </a:p>
         </p:txBody>
@@ -1158,7 +1158,7 @@
           <a:lstStyle/>
           <a:p>
             <a:r>
-              <a:t>~30 s. 6-19 Oct: every file reviewed with offline simulation tests (fake database, fake Redis, FastAPI test client; a Node harness with a fake browser for the extension): 30 and 56 checks, recorded in the commit messages. 22-25 Oct: thresholds re-measured on the re-embedded data; unit and integration tests for the 25 scenarios in the design document; code freeze on 25 Oct. 26-27 Oct: end-to-end run of all three sources, evaluation, rehearsal. Team: four equal shares; each member owns one area and cross-checks one area of another member (four equal shares).</a:t>
+              <a:t>~30 s. 6-19 Oct: every file reviewed with offline simulation tests (fake database, fake Redis, FastAPI test client; a Node harness with a fake browser for the extension): 30 and 56 checks, recorded in the commit messages. 22-25 Oct: final build and code freeze on 25 Oct. 26 Oct: 563 pytest tests (333 unit, 220 integration, 10 system, about 94 % line coverage, docs/review/ci_cd_guide.md; a re-run on a laptop without the mcp 2.x package ran 547 of them) and the live evaluation on the test account: 119 items, 38 questions, 15 scripted capture sessions, thresholds measured (docs/review/eval/RESULTS_2026-10-26.md). 27 Oct: rehearsal. Team: four equal shares; each member owns one area and cross-checks one area of another member (four equal shares).</a:t>
             </a:r>
           </a:p>
         </p:txBody>
@@ -1320,7 +1320,7 @@
           <a:lstStyle/>
           <a:p>
             <a:r>
-              <a:t>~40 s. The template asks for results versus expectations, reasons for any deviation, and a comparison with other methods. Nothing here is a result yet: replace every 'to be measured' with a value from the 26-27 Oct runs. Recall@5 and MRR on a fixed question set; keyword-only vs meaning-only vs hybrid; the previous embedding model vs the new one; median and 95th-percentile time per question; model calls and cost per question; enrichment speed and how many items each classification stage resolves. Do not present estimates as results.</a:t>
+              <a:t>~60 s. Everything here was measured on 26 Oct on the test account (docs/review/eval/RESULTS_2026-10-26.md). Questions and gold items were written by the team's assistant and are still to be checked by the owner; say 'first test set' if asked. Retrieval, 38 questions, 81 gold items: keyword only Recall@10 0.70, meaning only 0.96, rank fusion 0.96 (the keyword branch changed no top-10), full pipeline 0.93, MRR 0.99 for meaning only against 0.90 for the full pipeline. Cause found in q28 and q30: the cross-encoder scores are close to 0 for every candidate on these short questions, so the effort score decides the order. Answers contained the right fact in 11 of 11 questions that have one. Time: median 8.1 s, 95th percentile 23.8 s over 44 turns, on a laptop with about 1 GB free RAM, so likely pessimistic. Model calls 2.34 per turn (33 turns used 2, none needed all 5 searches). Cost: about $0.0021 per turn at an ASSUMED $0.20 and $1.20 per million input and output tokens (copied from an older model comment; gpt-6-luna's price is not checked). Embedding model: the 37/39 against 31/39 is from the model-choice test of 21 Oct (Echo_System_Design.md A40), a different 39-question set, not repeated on tonight's 38. Enrichment: 3.1 s per item, 19.3 items per minute including PDF text extraction; stages over all 119 items: structural 84, model 19, centroid 11, domain 5. Capture: 13 clean scripted sessions, all agree (Chrome 8 of 8, YouTube 5 of 5), run with a synthetic user in one tab. Privacy: the largest request was 38,469 characters; no item text beyond the cap appeared (a probe over only 2 long items). Thresholds measured: KNN bar 0.65 -&gt; 0.85, seed lead 0.08 -&gt; 0.05, search quality gate 0.55 kept.</a:t>
             </a:r>
           </a:p>
         </p:txBody>
@@ -1600,7 +1600,7 @@
           <a:lstStyle/>
           <a:p>
             <a:r>
-              <a:t>Left empty on purpose: paste the guide's approval mail here. It is not part of the Review 3 template; delete this slide if it is not wanted (build_deck_r3.py: INCLUDE_GUIDE_APPROVAL_SLIDE = False).</a:t>
+              <a:t>Screenshot of the guide's approval mail (Fri 23 Oct 2026, 7:32 PM): 'Dear Students your PPT is approved'. It is not part of the Review 3 template; delete this slide if it is not wanted (build_deck_r3.py: INCLUDE_GUIDE_APPROVAL_SLIDE = False).</a:t>
             </a:r>
           </a:p>
         </p:txBody>
@@ -1841,7 +1841,7 @@
           <a:lstStyle/>
           <a:p>
             <a:r>
-              <a:t>~45 s. The problem in one line (interview email, articles, tutorials, spread over three places). Then the three things E.C.H.O. does. Scope: one user, one laptop, desktop Chrome plus the Gmail API and YouTube. Privacy: storage and processing are local; only the question and short snippets go to the language model, never whole mails, pages or transcripts; the Gmail and YouTube APIs fetch your own data.</a:t>
+              <a:t>~45 s. The problem in one line (interview email, articles, tutorials, spread over three places). Then the three things E.C.H.O. does. Scope: one user, one laptop, desktop Chrome plus the Gmail API and YouTube. Privacy: storage and processing are local; the language model gets the question and limited excerpts (the first 8,000 characters of the top 3 results, 2,000 of the others), never database rows or the whole store; the Gmail and YouTube APIs fetch your own data.</a:t>
             </a:r>
           </a:p>
         </p:txBody>
@@ -2057,7 +2057,7 @@
           <a:lstStyle/>
           <a:p>
             <a:r>
-              <a:t>~60 s. Read it left to right: the life of one memory. Mail comes in through the Gmail API (checked every 30 s); pages and videos come in through the Chrome extension, whose background script is the only way data leaves the browser. Each connector writes through ONE storage engine, one transaction per item, into PostgreSQL (the permanent truth); FAISS holds the vectors and Redis the revisit flags and settings. The enrichment worker runs in the background: it reads new rows, writes vectors and groups, and asks the language model only about unclear items. The recall engine and the wellbeing module only read. The dashboard and the MCP server (Claude Desktop) call them. Only two things leave the laptop: the Google APIs, which return your own data, and the language model, which gets the question and short snippets. Wellbeing sends it weekly totals only.</a:t>
+              <a:t>~60 s. Read it left to right: the life of one memory. Mail comes in through the Gmail API (checked every 30 s); pages and videos come in through the Chrome extension, whose background script is the only way data leaves the browser. Each connector writes through ONE storage engine, one transaction per item, into PostgreSQL (the permanent truth); FAISS holds the vectors and Redis the revisit flags and settings. The enrichment worker runs in the background: it reads new rows, writes vectors and groups, and asks the language model only about unclear items. The recall engine and the wellbeing module only read. The dashboard and the MCP server (Claude Desktop) call them. Only two things leave the laptop: the Google APIs, which return your own data, and the language model, which gets the question and limited excerpts. Wellbeing sends it weekly totals only.</a:t>
             </a:r>
           </a:p>
         </p:txBody>
@@ -2324,7 +2324,7 @@
           <a:lstStyle/>
           <a:p>
             <a:r>
-              <a:t>~60 s, the core. The model decides WHAT to search for; HOW the search runs is fixed Python, and the model never touches the database. It calls one read-only tool, search_memories (query, sources, a time phrase such as 'after the interview email', an optional sender). Rounds are capped at 5, then it must answer: usually 2 model calls, at most 6, enforced in code. Python resolves the time phrase to a hard date filter, runs PostgreSQL full-text search and FAISS meaning search (three rephrasings) at the same time, and merges by rank with Reciprocal Rank Fusion. A quality check can widen the search up to three times. A local cross-encoder (ms-marco-MiniLM-L-6-v2) reads the question and each item together; the final score is 0.8 x cross-encoder + 0.2 x effort (time spent, scroll, revisits). Then the thread or the items within 5 minutes are added as context, and the model writes the answer from at most 10 snippets of 500 characters. Recency boost and diversity re-ranking are deliberately not used. If the model is down, a deterministic search runs on the raw question.</a:t>
+              <a:t>~60 s, the core. The model decides WHAT to search for; HOW the search runs is fixed Python, and the model never touches the database. It calls one read-only tool, search_memories (query, sources, a time phrase such as 'after the interview email', an optional sender). Rounds are capped at 5, then it must answer: usually 2 model calls, at most 6, enforced in code. Python resolves the time phrase to a hard date filter, runs PostgreSQL full-text search and FAISS meaning search (three rephrasings) at the same time, and merges by rank with Reciprocal Rank Fusion. A quality check can widen the search up to three times. A local cross-encoder (ms-marco-MiniLM-L-6-v2) reads the question and each item together; the final score is 0.8 x cross-encoder + 0.2 x effort (time spent, scroll, revisits). Then the thread or the items within 5 minutes are added as context, and the model writes the answer from the top 10 results (8,000 characters of text for the best 3, 2,000 for the rest). Recency boost and diversity re-ranking are deliberately not used. If the model is down, a deterministic search runs on the raw question.</a:t>
             </a:r>
           </a:p>
         </p:txBody>
@@ -2497,7 +2497,7 @@
             <a:fld id="{2D1A7037-0853-0447-B5BA-F1548123F733}" type="datetimeFigureOut">
               <a:rPr lang="en-US" smtClean="0"/>
               <a:pPr/>
-              <a:t>10/22/2026</a:t>
+              <a:t>10/26/2026</a:t>
             </a:fld>
             <a:endParaRPr lang="en-US"/>
           </a:p>
@@ -2697,7 +2697,7 @@
             <a:fld id="{2D1A7037-0853-0447-B5BA-F1548123F733}" type="datetimeFigureOut">
               <a:rPr lang="en-US" smtClean="0"/>
               <a:pPr/>
-              <a:t>10/22/2026</a:t>
+              <a:t>10/26/2026</a:t>
             </a:fld>
             <a:endParaRPr lang="en-US"/>
           </a:p>
@@ -2974,7 +2974,7 @@
             <a:fld id="{2D1A7037-0853-0447-B5BA-F1548123F733}" type="datetimeFigureOut">
               <a:rPr lang="en-US" smtClean="0"/>
               <a:pPr/>
-              <a:t>10/22/2026</a:t>
+              <a:t>10/26/2026</a:t>
             </a:fld>
             <a:endParaRPr lang="en-US"/>
           </a:p>
@@ -3241,7 +3241,7 @@
             <a:fld id="{2D1A7037-0853-0447-B5BA-F1548123F733}" type="datetimeFigureOut">
               <a:rPr lang="en-US" smtClean="0"/>
               <a:pPr/>
-              <a:t>10/22/2026</a:t>
+              <a:t>10/26/2026</a:t>
             </a:fld>
             <a:endParaRPr lang="en-US"/>
           </a:p>
@@ -3655,7 +3655,7 @@
             <a:fld id="{2D1A7037-0853-0447-B5BA-F1548123F733}" type="datetimeFigureOut">
               <a:rPr lang="en-US" smtClean="0"/>
               <a:pPr/>
-              <a:t>10/22/2026</a:t>
+              <a:t>10/26/2026</a:t>
             </a:fld>
             <a:endParaRPr lang="en-US"/>
           </a:p>
@@ -3798,7 +3798,7 @@
             <a:fld id="{2D1A7037-0853-0447-B5BA-F1548123F733}" type="datetimeFigureOut">
               <a:rPr lang="en-US" smtClean="0"/>
               <a:pPr/>
-              <a:t>10/22/2026</a:t>
+              <a:t>10/26/2026</a:t>
             </a:fld>
             <a:endParaRPr lang="en-US"/>
           </a:p>
@@ -3913,7 +3913,7 @@
             <a:fld id="{2D1A7037-0853-0447-B5BA-F1548123F733}" type="datetimeFigureOut">
               <a:rPr lang="en-US" smtClean="0"/>
               <a:pPr/>
-              <a:t>10/22/2026</a:t>
+              <a:t>10/26/2026</a:t>
             </a:fld>
             <a:endParaRPr lang="en-US"/>
           </a:p>
@@ -4226,7 +4226,7 @@
             <a:fld id="{2D1A7037-0853-0447-B5BA-F1548123F733}" type="datetimeFigureOut">
               <a:rPr lang="en-US" smtClean="0"/>
               <a:pPr/>
-              <a:t>10/22/2026</a:t>
+              <a:t>10/26/2026</a:t>
             </a:fld>
             <a:endParaRPr lang="en-US"/>
           </a:p>
@@ -4519,7 +4519,7 @@
             <a:fld id="{2D1A7037-0853-0447-B5BA-F1548123F733}" type="datetimeFigureOut">
               <a:rPr lang="en-US" smtClean="0"/>
               <a:pPr/>
-              <a:t>10/22/2026</a:t>
+              <a:t>10/26/2026</a:t>
             </a:fld>
             <a:endParaRPr lang="en-US"/>
           </a:p>
@@ -4762,7 +4762,7 @@
             <a:fld id="{2D1A7037-0853-0447-B5BA-F1548123F733}" type="datetimeFigureOut">
               <a:rPr lang="en-US" smtClean="0"/>
               <a:pPr/>
-              <a:t>10/22/2026</a:t>
+              <a:t>10/26/2026</a:t>
             </a:fld>
             <a:endParaRPr lang="en-US"/>
           </a:p>
@@ -7413,7 +7413,7 @@
                 </a:solidFill>
                 <a:latin typeface="Trebuchet MS"/>
               </a:rPr>
-              <a:t>your question and short snippets of the best matches, never full emails or pages.</a:t>
+              <a:t>your question and limited excerpts of the best matches (first 8,000 characters of the top 3), never database rows.</a:t>
             </a:r>
             <a:endParaRPr sz="1900"/>
           </a:p>
@@ -9792,7 +9792,7 @@
                 </a:solidFill>
                 <a:latin typeface="Trebuchet MS"/>
               </a:rPr>
-              <a:t>Confident = a rule matches and similarity is above the bar</a:t>
+              <a:t>Confident = a rule matches and similarity is above 0.85</a:t>
             </a:r>
             <a:endParaRPr sz="1900"/>
           </a:p>
@@ -11648,7 +11648,7 @@
                 </a:solidFill>
                 <a:latin typeface="Trebuchet MS"/>
               </a:rPr>
-              <a:t>Thresholds re-measured; tests written for the 25 scenarios</a:t>
+              <a:t>Final build and code freeze on 25 Oct</a:t>
             </a:r>
             <a:endParaRPr sz="2000"/>
           </a:p>
@@ -11884,7 +11884,7 @@
                 </a:solidFill>
                 <a:latin typeface="Trebuchet MS"/>
               </a:rPr>
-              <a:t>End-to-end run of all three sources and rehearsal</a:t>
+              <a:t>563 tests; 38 questions, 15 capture sessions and 3 thresholds measured</a:t>
             </a:r>
             <a:endParaRPr sz="2000"/>
           </a:p>
@@ -13631,7 +13631,7 @@
                 </a:solidFill>
                 <a:latin typeface="Trebuchet MS"/>
               </a:rPr>
-              <a:t>25 scenarios · Gmail 5 · Chrome 7 · YouTube 4 · Recall 4 · Groups 2 · Enrichment 1 · Retention 1 · Privacy 1</a:t>
+              <a:t>563 automated tests (333 unit · 220 integration · 10 system), 94 % line coverage, run on every push · 38 recall questions · 15 capture sessions</a:t>
             </a:r>
             <a:endParaRPr sz="1900"/>
           </a:p>
@@ -14103,7 +14103,7 @@
         <p:spPr>
           <a:xfrm>
             <a:off x="640080" y="1874519"/>
-            <a:ext cx="10908792" cy="960120"/>
+            <a:ext cx="10908792" cy="1371600"/>
           </a:xfrm>
           <a:prstGeom prst="roundRect">
             <a:avLst>
@@ -14140,28 +14140,72 @@
           <a:p>
             <a:pPr algn="l">
               <a:spcAft>
+                <a:spcPts val="300"/>
+              </a:spcAft>
+            </a:pPr>
+            <a:r>
+              <a:rPr sz="1800" b="1" i="0">
+                <a:solidFill>
+                  <a:srgbClr val="10204A"/>
+                </a:solidFill>
+                <a:latin typeface="Trebuchet MS"/>
+              </a:rPr>
+              <a:t>Test set: </a:t>
+            </a:r>
+            <a:r>
+              <a:rPr sz="1800" b="0" i="0">
+                <a:solidFill>
+                  <a:srgbClr val="10204A"/>
+                </a:solidFill>
+                <a:latin typeface="Trebuchet MS"/>
+              </a:rPr>
+              <a:t>119 items, 38 questions, test account. </a:t>
+            </a:r>
+            <a:r>
+              <a:rPr sz="1800" b="1" i="0">
+                <a:solidFill>
+                  <a:srgbClr val="10204A"/>
+                </a:solidFill>
+                <a:latin typeface="Trebuchet MS"/>
+              </a:rPr>
+              <a:t>Finding: </a:t>
+            </a:r>
+            <a:r>
+              <a:rPr sz="1800" b="0" i="0">
+                <a:solidFill>
+                  <a:srgbClr val="10204A"/>
+                </a:solidFill>
+                <a:latin typeface="Trebuchet MS"/>
+              </a:rPr>
+              <a:t>meaning search alone ranked best (MRR 0.99); the cross-encoder step lowered it to 0.90 on this small set.</a:t>
+            </a:r>
+            <a:endParaRPr sz="1800"/>
+          </a:p>
+          <a:p>
+            <a:pPr algn="l">
+              <a:spcAft>
                 <a:spcPts val="0"/>
               </a:spcAft>
             </a:pPr>
             <a:r>
-              <a:rPr sz="2000" b="1" i="0">
+              <a:rPr sz="1800" b="1" i="0">
                 <a:solidFill>
                   <a:srgbClr val="10204A"/>
                 </a:solidFill>
                 <a:latin typeface="Trebuchet MS"/>
               </a:rPr>
-              <a:t>The evaluation runs after the new embedding model is switched in and every item is re-embedded. </a:t>
-            </a:r>
-            <a:r>
-              <a:rPr sz="2000" b="0" i="0">
+              <a:t>Also: </a:t>
+            </a:r>
+            <a:r>
+              <a:rPr sz="1800" b="0" i="0">
                 <a:solidFill>
                   <a:srgbClr val="10204A"/>
                 </a:solidFill>
                 <a:latin typeface="Trebuchet MS"/>
               </a:rPr>
-              <a:t>All fields the template asks for will be measured on that same data.</a:t>
-            </a:r>
-            <a:endParaRPr sz="2000"/>
+              <a:t>13 of 13 clean capture sessions matched the design; no text past the 8,000-character cap was sent to the model.</a:t>
+            </a:r>
+            <a:endParaRPr sz="1800"/>
           </a:p>
         </p:txBody>
       </p:sp>
@@ -14173,8 +14217,8 @@
         </p:nvSpPr>
         <p:spPr>
           <a:xfrm>
-            <a:off x="640080" y="2971799"/>
-            <a:ext cx="5340096" cy="1106424"/>
+            <a:off x="640080" y="3355848"/>
+            <a:ext cx="5340096" cy="990599"/>
           </a:xfrm>
           <a:prstGeom prst="roundRect">
             <a:avLst>
@@ -14224,8 +14268,8 @@
         </p:nvSpPr>
         <p:spPr>
           <a:xfrm>
-            <a:off x="640080" y="3081527"/>
-            <a:ext cx="73152" cy="886968"/>
+            <a:off x="640080" y="3447288"/>
+            <a:ext cx="73152" cy="807720"/>
           </a:xfrm>
           <a:prstGeom prst="rect">
             <a:avLst/>
@@ -14269,8 +14313,8 @@
         </p:nvSpPr>
         <p:spPr>
           <a:xfrm>
-            <a:off x="822959" y="2971799"/>
-            <a:ext cx="2825496" cy="1106424"/>
+            <a:off x="822959" y="3355848"/>
+            <a:ext cx="5065776" cy="990599"/>
           </a:xfrm>
           <a:prstGeom prst="rect">
             <a:avLst/>
@@ -14278,26 +14322,26 @@
           <a:noFill/>
         </p:spPr>
         <p:txBody>
-          <a:bodyPr wrap="square" lIns="54864" tIns="32918" rIns="54864" bIns="32918" anchor="ctr">
+          <a:bodyPr wrap="square" lIns="36576" tIns="21945" rIns="36576" bIns="21945" anchor="ctr">
             <a:spAutoFit/>
           </a:bodyPr>
           <a:lstStyle/>
           <a:p>
             <a:pPr algn="l">
               <a:spcAft>
-                <a:spcPts val="100"/>
-              </a:spcAft>
-            </a:pPr>
-            <a:r>
-              <a:rPr sz="2000" b="1" i="0">
-                <a:solidFill>
-                  <a:srgbClr val="10204A"/>
+                <a:spcPts val="0"/>
+              </a:spcAft>
+            </a:pPr>
+            <a:r>
+              <a:rPr sz="1900" b="1" i="0">
+                <a:solidFill>
+                  <a:srgbClr val="455068"/>
                 </a:solidFill>
                 <a:latin typeface="Trebuchet MS"/>
               </a:rPr>
               <a:t>Retrieval quality</a:t>
             </a:r>
-            <a:endParaRPr sz="2000"/>
+            <a:endParaRPr sz="1900"/>
           </a:p>
           <a:p>
             <a:pPr algn="l">
@@ -14306,13 +14350,30 @@
               </a:spcAft>
             </a:pPr>
             <a:r>
+              <a:rPr sz="2100" b="1" i="0">
+                <a:solidFill>
+                  <a:srgbClr val="0B2272"/>
+                </a:solidFill>
+                <a:latin typeface="Trebuchet MS"/>
+              </a:rPr>
+              <a:t>Recall@5 0.91 · MRR 0.90</a:t>
+            </a:r>
+            <a:endParaRPr sz="2100"/>
+          </a:p>
+          <a:p>
+            <a:pPr algn="l">
+              <a:spcAft>
+                <a:spcPts val="0"/>
+              </a:spcAft>
+            </a:pPr>
+            <a:r>
               <a:rPr sz="1800" b="0" i="0">
                 <a:solidFill>
                   <a:srgbClr val="455068"/>
                 </a:solidFill>
                 <a:latin typeface="Trebuchet MS"/>
               </a:rPr>
-              <a:t>Recall@5 · MRR on a fixed question set</a:t>
+              <a:t>full agent loop; Recall@10 0.93</a:t>
             </a:r>
             <a:endParaRPr sz="1800"/>
           </a:p>
@@ -14326,70 +14387,8 @@
         </p:nvSpPr>
         <p:spPr>
           <a:xfrm>
-            <a:off x="3694176" y="3314699"/>
-            <a:ext cx="2148840" cy="420624"/>
-          </a:xfrm>
-          <a:prstGeom prst="roundRect">
-            <a:avLst>
-              <a:gd name="adj" fmla="val 50000"/>
-            </a:avLst>
-          </a:prstGeom>
-          <a:solidFill>
-            <a:srgbClr val="EEF1F7"/>
-          </a:solidFill>
-          <a:ln w="12700">
-            <a:solidFill>
-              <a:srgbClr val="4A556E"/>
-            </a:solidFill>
-          </a:ln>
-          <a:effectLst/>
-        </p:spPr>
-        <p:style>
-          <a:lnRef idx="1">
-            <a:schemeClr val="accent1"/>
-          </a:lnRef>
-          <a:fillRef idx="3">
-            <a:schemeClr val="accent1"/>
-          </a:fillRef>
-          <a:effectRef idx="2">
-            <a:schemeClr val="accent1"/>
-          </a:effectRef>
-          <a:fontRef idx="minor">
-            <a:schemeClr val="lt1"/>
-          </a:fontRef>
-        </p:style>
-        <p:txBody>
-          <a:bodyPr wrap="square" lIns="27432" tIns="16459" rIns="27432" bIns="16459" rtlCol="0" anchor="ctr"/>
-          <a:lstStyle/>
-          <a:p>
-            <a:pPr algn="ctr">
-              <a:spcAft>
-                <a:spcPts val="0"/>
-              </a:spcAft>
-            </a:pPr>
-            <a:r>
-              <a:rPr sz="1800" b="1" i="0">
-                <a:solidFill>
-                  <a:srgbClr val="1E263A"/>
-                </a:solidFill>
-                <a:latin typeface="Trebuchet MS"/>
-              </a:rPr>
-              <a:t>to be measured</a:t>
-            </a:r>
-            <a:endParaRPr sz="1800"/>
-          </a:p>
-        </p:txBody>
-      </p:sp>
-      <p:sp>
-        <p:nvSpPr>
-          <p:cNvPr id="9" name="Rounded Rectangle 8"/>
-          <p:cNvSpPr/>
-          <p:nvPr/>
-        </p:nvSpPr>
-        <p:spPr>
-          <a:xfrm>
-            <a:off x="640080" y="4187952"/>
-            <a:ext cx="5340096" cy="1106424"/>
+            <a:off x="640080" y="4437888"/>
+            <a:ext cx="5340096" cy="990599"/>
           </a:xfrm>
           <a:prstGeom prst="roundRect">
             <a:avLst>
@@ -14433,14 +14432,14 @@
       </p:sp>
       <p:sp>
         <p:nvSpPr>
-          <p:cNvPr id="10" name="Rectangle 9"/>
+          <p:cNvPr id="9" name="Rectangle 8"/>
           <p:cNvSpPr/>
           <p:nvPr/>
         </p:nvSpPr>
         <p:spPr>
           <a:xfrm>
-            <a:off x="640080" y="4297680"/>
-            <a:ext cx="73152" cy="886968"/>
+            <a:off x="640080" y="4529328"/>
+            <a:ext cx="73152" cy="807720"/>
           </a:xfrm>
           <a:prstGeom prst="rect">
             <a:avLst/>
@@ -14478,14 +14477,14 @@
       </p:sp>
       <p:sp>
         <p:nvSpPr>
-          <p:cNvPr id="11" name="TextBox 10"/>
+          <p:cNvPr id="10" name="TextBox 9"/>
           <p:cNvSpPr txBox="1"/>
           <p:nvPr/>
         </p:nvSpPr>
         <p:spPr>
           <a:xfrm>
-            <a:off x="822959" y="4187952"/>
-            <a:ext cx="2825496" cy="1106424"/>
+            <a:off x="822959" y="4437888"/>
+            <a:ext cx="5065776" cy="990599"/>
           </a:xfrm>
           <a:prstGeom prst="rect">
             <a:avLst/>
@@ -14493,26 +14492,26 @@
           <a:noFill/>
         </p:spPr>
         <p:txBody>
-          <a:bodyPr wrap="square" lIns="54864" tIns="32918" rIns="54864" bIns="32918" anchor="ctr">
+          <a:bodyPr wrap="square" lIns="36576" tIns="21945" rIns="36576" bIns="21945" anchor="ctr">
             <a:spAutoFit/>
           </a:bodyPr>
           <a:lstStyle/>
           <a:p>
             <a:pPr algn="l">
               <a:spcAft>
-                <a:spcPts val="100"/>
-              </a:spcAft>
-            </a:pPr>
-            <a:r>
-              <a:rPr sz="2000" b="1" i="0">
-                <a:solidFill>
-                  <a:srgbClr val="10204A"/>
+                <a:spcPts val="0"/>
+              </a:spcAft>
+            </a:pPr>
+            <a:r>
+              <a:rPr sz="1900" b="1" i="0">
+                <a:solidFill>
+                  <a:srgbClr val="455068"/>
                 </a:solidFill>
                 <a:latin typeface="Trebuchet MS"/>
               </a:rPr>
               <a:t>Search methods</a:t>
             </a:r>
-            <a:endParaRPr sz="2000"/>
+            <a:endParaRPr sz="1900"/>
           </a:p>
           <a:p>
             <a:pPr algn="l">
@@ -14521,13 +14520,30 @@
               </a:spcAft>
             </a:pPr>
             <a:r>
+              <a:rPr sz="2100" b="1" i="0">
+                <a:solidFill>
+                  <a:srgbClr val="0B2272"/>
+                </a:solidFill>
+                <a:latin typeface="Trebuchet MS"/>
+              </a:rPr>
+              <a:t>Recall@10: 0.70 · 0.96 · 0.96</a:t>
+            </a:r>
+            <a:endParaRPr sz="2100"/>
+          </a:p>
+          <a:p>
+            <a:pPr algn="l">
+              <a:spcAft>
+                <a:spcPts val="0"/>
+              </a:spcAft>
+            </a:pPr>
+            <a:r>
               <a:rPr sz="1800" b="0" i="0">
                 <a:solidFill>
                   <a:srgbClr val="455068"/>
                 </a:solidFill>
                 <a:latin typeface="Trebuchet MS"/>
               </a:rPr>
-              <a:t>keyword-only · meaning-only · hybrid</a:t>
+              <a:t>keyword · meaning · hybrid (rank fusion)</a:t>
             </a:r>
             <a:endParaRPr sz="1800"/>
           </a:p>
@@ -14535,76 +14551,14 @@
       </p:sp>
       <p:sp>
         <p:nvSpPr>
-          <p:cNvPr id="12" name="Rounded Rectangle 11"/>
+          <p:cNvPr id="11" name="Rounded Rectangle 10"/>
           <p:cNvSpPr/>
           <p:nvPr/>
         </p:nvSpPr>
         <p:spPr>
           <a:xfrm>
-            <a:off x="3694176" y="4530852"/>
-            <a:ext cx="2148840" cy="420624"/>
-          </a:xfrm>
-          <a:prstGeom prst="roundRect">
-            <a:avLst>
-              <a:gd name="adj" fmla="val 50000"/>
-            </a:avLst>
-          </a:prstGeom>
-          <a:solidFill>
-            <a:srgbClr val="EEF1F7"/>
-          </a:solidFill>
-          <a:ln w="12700">
-            <a:solidFill>
-              <a:srgbClr val="4A556E"/>
-            </a:solidFill>
-          </a:ln>
-          <a:effectLst/>
-        </p:spPr>
-        <p:style>
-          <a:lnRef idx="1">
-            <a:schemeClr val="accent1"/>
-          </a:lnRef>
-          <a:fillRef idx="3">
-            <a:schemeClr val="accent1"/>
-          </a:fillRef>
-          <a:effectRef idx="2">
-            <a:schemeClr val="accent1"/>
-          </a:effectRef>
-          <a:fontRef idx="minor">
-            <a:schemeClr val="lt1"/>
-          </a:fontRef>
-        </p:style>
-        <p:txBody>
-          <a:bodyPr wrap="square" lIns="27432" tIns="16459" rIns="27432" bIns="16459" rtlCol="0" anchor="ctr"/>
-          <a:lstStyle/>
-          <a:p>
-            <a:pPr algn="ctr">
-              <a:spcAft>
-                <a:spcPts val="0"/>
-              </a:spcAft>
-            </a:pPr>
-            <a:r>
-              <a:rPr sz="1800" b="1" i="0">
-                <a:solidFill>
-                  <a:srgbClr val="1E263A"/>
-                </a:solidFill>
-                <a:latin typeface="Trebuchet MS"/>
-              </a:rPr>
-              <a:t>to be measured</a:t>
-            </a:r>
-            <a:endParaRPr sz="1800"/>
-          </a:p>
-        </p:txBody>
-      </p:sp>
-      <p:sp>
-        <p:nvSpPr>
-          <p:cNvPr id="13" name="Rounded Rectangle 12"/>
-          <p:cNvSpPr/>
-          <p:nvPr/>
-        </p:nvSpPr>
-        <p:spPr>
-          <a:xfrm>
-            <a:off x="640080" y="5404104"/>
-            <a:ext cx="5340096" cy="1106424"/>
+            <a:off x="640080" y="5519928"/>
+            <a:ext cx="5340096" cy="990599"/>
           </a:xfrm>
           <a:prstGeom prst="roundRect">
             <a:avLst>
@@ -14648,14 +14602,14 @@
       </p:sp>
       <p:sp>
         <p:nvSpPr>
-          <p:cNvPr id="14" name="Rectangle 13"/>
+          <p:cNvPr id="12" name="Rectangle 11"/>
           <p:cNvSpPr/>
           <p:nvPr/>
         </p:nvSpPr>
         <p:spPr>
           <a:xfrm>
-            <a:off x="640080" y="5513832"/>
-            <a:ext cx="73152" cy="886968"/>
+            <a:off x="640080" y="5611368"/>
+            <a:ext cx="73152" cy="807720"/>
           </a:xfrm>
           <a:prstGeom prst="rect">
             <a:avLst/>
@@ -14693,14 +14647,14 @@
       </p:sp>
       <p:sp>
         <p:nvSpPr>
-          <p:cNvPr id="15" name="TextBox 14"/>
+          <p:cNvPr id="13" name="TextBox 12"/>
           <p:cNvSpPr txBox="1"/>
           <p:nvPr/>
         </p:nvSpPr>
         <p:spPr>
           <a:xfrm>
-            <a:off x="822959" y="5404104"/>
-            <a:ext cx="2825496" cy="1106424"/>
+            <a:off x="822959" y="5519928"/>
+            <a:ext cx="5065776" cy="990599"/>
           </a:xfrm>
           <a:prstGeom prst="rect">
             <a:avLst/>
@@ -14708,26 +14662,26 @@
           <a:noFill/>
         </p:spPr>
         <p:txBody>
-          <a:bodyPr wrap="square" lIns="54864" tIns="32918" rIns="54864" bIns="32918" anchor="ctr">
+          <a:bodyPr wrap="square" lIns="36576" tIns="21945" rIns="36576" bIns="21945" anchor="ctr">
             <a:spAutoFit/>
           </a:bodyPr>
           <a:lstStyle/>
           <a:p>
             <a:pPr algn="l">
               <a:spcAft>
-                <a:spcPts val="100"/>
-              </a:spcAft>
-            </a:pPr>
-            <a:r>
-              <a:rPr sz="2000" b="1" i="0">
-                <a:solidFill>
-                  <a:srgbClr val="10204A"/>
+                <a:spcPts val="0"/>
+              </a:spcAft>
+            </a:pPr>
+            <a:r>
+              <a:rPr sz="1900" b="1" i="0">
+                <a:solidFill>
+                  <a:srgbClr val="455068"/>
                 </a:solidFill>
                 <a:latin typeface="Trebuchet MS"/>
               </a:rPr>
               <a:t>Embedding model</a:t>
             </a:r>
-            <a:endParaRPr sz="2000"/>
+            <a:endParaRPr sz="1900"/>
           </a:p>
           <a:p>
             <a:pPr algn="l">
@@ -14736,13 +14690,30 @@
               </a:spcAft>
             </a:pPr>
             <a:r>
+              <a:rPr sz="2100" b="1" i="0">
+                <a:solidFill>
+                  <a:srgbClr val="0B2272"/>
+                </a:solidFill>
+                <a:latin typeface="Trebuchet MS"/>
+              </a:rPr>
+              <a:t>Right item first: 37 vs 31 of 39</a:t>
+            </a:r>
+            <a:endParaRPr sz="2100"/>
+          </a:p>
+          <a:p>
+            <a:pPr algn="l">
+              <a:spcAft>
+                <a:spcPts val="0"/>
+              </a:spcAft>
+            </a:pPr>
+            <a:r>
               <a:rPr sz="1800" b="0" i="0">
                 <a:solidFill>
                   <a:srgbClr val="455068"/>
                 </a:solidFill>
                 <a:latin typeface="Trebuchet MS"/>
               </a:rPr>
-              <a:t>previous model vs the new one</a:t>
+              <a:t>new model vs MiniLM, earlier 39-question test</a:t>
             </a:r>
             <a:endParaRPr sz="1800"/>
           </a:p>
@@ -14750,76 +14721,14 @@
       </p:sp>
       <p:sp>
         <p:nvSpPr>
-          <p:cNvPr id="16" name="Rounded Rectangle 15"/>
+          <p:cNvPr id="14" name="Rounded Rectangle 13"/>
           <p:cNvSpPr/>
           <p:nvPr/>
         </p:nvSpPr>
         <p:spPr>
           <a:xfrm>
-            <a:off x="3694176" y="5747004"/>
-            <a:ext cx="2148840" cy="420624"/>
-          </a:xfrm>
-          <a:prstGeom prst="roundRect">
-            <a:avLst>
-              <a:gd name="adj" fmla="val 50000"/>
-            </a:avLst>
-          </a:prstGeom>
-          <a:solidFill>
-            <a:srgbClr val="EEF1F7"/>
-          </a:solidFill>
-          <a:ln w="12700">
-            <a:solidFill>
-              <a:srgbClr val="4A556E"/>
-            </a:solidFill>
-          </a:ln>
-          <a:effectLst/>
-        </p:spPr>
-        <p:style>
-          <a:lnRef idx="1">
-            <a:schemeClr val="accent1"/>
-          </a:lnRef>
-          <a:fillRef idx="3">
-            <a:schemeClr val="accent1"/>
-          </a:fillRef>
-          <a:effectRef idx="2">
-            <a:schemeClr val="accent1"/>
-          </a:effectRef>
-          <a:fontRef idx="minor">
-            <a:schemeClr val="lt1"/>
-          </a:fontRef>
-        </p:style>
-        <p:txBody>
-          <a:bodyPr wrap="square" lIns="27432" tIns="16459" rIns="27432" bIns="16459" rtlCol="0" anchor="ctr"/>
-          <a:lstStyle/>
-          <a:p>
-            <a:pPr algn="ctr">
-              <a:spcAft>
-                <a:spcPts val="0"/>
-              </a:spcAft>
-            </a:pPr>
-            <a:r>
-              <a:rPr sz="1800" b="1" i="0">
-                <a:solidFill>
-                  <a:srgbClr val="1E263A"/>
-                </a:solidFill>
-                <a:latin typeface="Trebuchet MS"/>
-              </a:rPr>
-              <a:t>to be measured</a:t>
-            </a:r>
-            <a:endParaRPr sz="1800"/>
-          </a:p>
-        </p:txBody>
-      </p:sp>
-      <p:sp>
-        <p:nvSpPr>
-          <p:cNvPr id="17" name="Rounded Rectangle 16"/>
-          <p:cNvSpPr/>
-          <p:nvPr/>
-        </p:nvSpPr>
-        <p:spPr>
-          <a:xfrm>
-            <a:off x="6208776" y="2971799"/>
-            <a:ext cx="5340096" cy="1106424"/>
+            <a:off x="6208776" y="3355848"/>
+            <a:ext cx="5340096" cy="990599"/>
           </a:xfrm>
           <a:prstGeom prst="roundRect">
             <a:avLst>
@@ -14863,14 +14772,14 @@
       </p:sp>
       <p:sp>
         <p:nvSpPr>
-          <p:cNvPr id="18" name="Rectangle 17"/>
+          <p:cNvPr id="15" name="Rectangle 14"/>
           <p:cNvSpPr/>
           <p:nvPr/>
         </p:nvSpPr>
         <p:spPr>
           <a:xfrm>
-            <a:off x="6208776" y="3081527"/>
-            <a:ext cx="73152" cy="886968"/>
+            <a:off x="6208776" y="3447288"/>
+            <a:ext cx="73152" cy="807720"/>
           </a:xfrm>
           <a:prstGeom prst="rect">
             <a:avLst/>
@@ -14908,14 +14817,14 @@
       </p:sp>
       <p:sp>
         <p:nvSpPr>
-          <p:cNvPr id="19" name="TextBox 18"/>
+          <p:cNvPr id="16" name="TextBox 15"/>
           <p:cNvSpPr txBox="1"/>
           <p:nvPr/>
         </p:nvSpPr>
         <p:spPr>
           <a:xfrm>
-            <a:off x="6391656" y="2971799"/>
-            <a:ext cx="2825496" cy="1106424"/>
+            <a:off x="6391656" y="3355848"/>
+            <a:ext cx="5065776" cy="990599"/>
           </a:xfrm>
           <a:prstGeom prst="rect">
             <a:avLst/>
@@ -14923,26 +14832,26 @@
           <a:noFill/>
         </p:spPr>
         <p:txBody>
-          <a:bodyPr wrap="square" lIns="54864" tIns="32918" rIns="54864" bIns="32918" anchor="ctr">
+          <a:bodyPr wrap="square" lIns="36576" tIns="21945" rIns="36576" bIns="21945" anchor="ctr">
             <a:spAutoFit/>
           </a:bodyPr>
           <a:lstStyle/>
           <a:p>
             <a:pPr algn="l">
               <a:spcAft>
-                <a:spcPts val="100"/>
-              </a:spcAft>
-            </a:pPr>
-            <a:r>
-              <a:rPr sz="2000" b="1" i="0">
-                <a:solidFill>
-                  <a:srgbClr val="10204A"/>
+                <a:spcPts val="0"/>
+              </a:spcAft>
+            </a:pPr>
+            <a:r>
+              <a:rPr sz="1900" b="1" i="0">
+                <a:solidFill>
+                  <a:srgbClr val="455068"/>
                 </a:solidFill>
                 <a:latin typeface="Trebuchet MS"/>
               </a:rPr>
               <a:t>Time per question</a:t>
             </a:r>
-            <a:endParaRPr sz="2000"/>
+            <a:endParaRPr sz="1900"/>
           </a:p>
           <a:p>
             <a:pPr algn="l">
@@ -14951,13 +14860,30 @@
               </a:spcAft>
             </a:pPr>
             <a:r>
+              <a:rPr sz="2100" b="1" i="0">
+                <a:solidFill>
+                  <a:srgbClr val="0B2272"/>
+                </a:solidFill>
+                <a:latin typeface="Trebuchet MS"/>
+              </a:rPr>
+              <a:t>8.1 s median · 23.8 s p95</a:t>
+            </a:r>
+            <a:endParaRPr sz="2100"/>
+          </a:p>
+          <a:p>
+            <a:pPr algn="l">
+              <a:spcAft>
+                <a:spcPts val="0"/>
+              </a:spcAft>
+            </a:pPr>
+            <a:r>
               <a:rPr sz="1800" b="0" i="0">
                 <a:solidFill>
                   <a:srgbClr val="455068"/>
                 </a:solidFill>
                 <a:latin typeface="Trebuchet MS"/>
               </a:rPr>
-              <a:t>median · 95th percentile</a:t>
+              <a:t>44 turns, a memory-starved laptop</a:t>
             </a:r>
             <a:endParaRPr sz="1800"/>
           </a:p>
@@ -14965,76 +14891,14 @@
       </p:sp>
       <p:sp>
         <p:nvSpPr>
-          <p:cNvPr id="20" name="Rounded Rectangle 19"/>
+          <p:cNvPr id="17" name="Rounded Rectangle 16"/>
           <p:cNvSpPr/>
           <p:nvPr/>
         </p:nvSpPr>
         <p:spPr>
           <a:xfrm>
-            <a:off x="9262872" y="3314699"/>
-            <a:ext cx="2148840" cy="420624"/>
-          </a:xfrm>
-          <a:prstGeom prst="roundRect">
-            <a:avLst>
-              <a:gd name="adj" fmla="val 50000"/>
-            </a:avLst>
-          </a:prstGeom>
-          <a:solidFill>
-            <a:srgbClr val="EEF1F7"/>
-          </a:solidFill>
-          <a:ln w="12700">
-            <a:solidFill>
-              <a:srgbClr val="4A556E"/>
-            </a:solidFill>
-          </a:ln>
-          <a:effectLst/>
-        </p:spPr>
-        <p:style>
-          <a:lnRef idx="1">
-            <a:schemeClr val="accent1"/>
-          </a:lnRef>
-          <a:fillRef idx="3">
-            <a:schemeClr val="accent1"/>
-          </a:fillRef>
-          <a:effectRef idx="2">
-            <a:schemeClr val="accent1"/>
-          </a:effectRef>
-          <a:fontRef idx="minor">
-            <a:schemeClr val="lt1"/>
-          </a:fontRef>
-        </p:style>
-        <p:txBody>
-          <a:bodyPr wrap="square" lIns="27432" tIns="16459" rIns="27432" bIns="16459" rtlCol="0" anchor="ctr"/>
-          <a:lstStyle/>
-          <a:p>
-            <a:pPr algn="ctr">
-              <a:spcAft>
-                <a:spcPts val="0"/>
-              </a:spcAft>
-            </a:pPr>
-            <a:r>
-              <a:rPr sz="1800" b="1" i="0">
-                <a:solidFill>
-                  <a:srgbClr val="1E263A"/>
-                </a:solidFill>
-                <a:latin typeface="Trebuchet MS"/>
-              </a:rPr>
-              <a:t>to be measured</a:t>
-            </a:r>
-            <a:endParaRPr sz="1800"/>
-          </a:p>
-        </p:txBody>
-      </p:sp>
-      <p:sp>
-        <p:nvSpPr>
-          <p:cNvPr id="21" name="Rounded Rectangle 20"/>
-          <p:cNvSpPr/>
-          <p:nvPr/>
-        </p:nvSpPr>
-        <p:spPr>
-          <a:xfrm>
-            <a:off x="6208776" y="4187952"/>
-            <a:ext cx="5340096" cy="1106424"/>
+            <a:off x="6208776" y="4437888"/>
+            <a:ext cx="5340096" cy="990599"/>
           </a:xfrm>
           <a:prstGeom prst="roundRect">
             <a:avLst>
@@ -15078,14 +14942,14 @@
       </p:sp>
       <p:sp>
         <p:nvSpPr>
-          <p:cNvPr id="22" name="Rectangle 21"/>
+          <p:cNvPr id="18" name="Rectangle 17"/>
           <p:cNvSpPr/>
           <p:nvPr/>
         </p:nvSpPr>
         <p:spPr>
           <a:xfrm>
-            <a:off x="6208776" y="4297680"/>
-            <a:ext cx="73152" cy="886968"/>
+            <a:off x="6208776" y="4529328"/>
+            <a:ext cx="73152" cy="807720"/>
           </a:xfrm>
           <a:prstGeom prst="rect">
             <a:avLst/>
@@ -15123,14 +14987,14 @@
       </p:sp>
       <p:sp>
         <p:nvSpPr>
-          <p:cNvPr id="23" name="TextBox 22"/>
+          <p:cNvPr id="19" name="TextBox 18"/>
           <p:cNvSpPr txBox="1"/>
           <p:nvPr/>
         </p:nvSpPr>
         <p:spPr>
           <a:xfrm>
-            <a:off x="6391656" y="4187952"/>
-            <a:ext cx="2825496" cy="1106424"/>
+            <a:off x="6391656" y="4437888"/>
+            <a:ext cx="5065776" cy="990599"/>
           </a:xfrm>
           <a:prstGeom prst="rect">
             <a:avLst/>
@@ -15138,26 +15002,26 @@
           <a:noFill/>
         </p:spPr>
         <p:txBody>
-          <a:bodyPr wrap="square" lIns="54864" tIns="32918" rIns="54864" bIns="32918" anchor="ctr">
+          <a:bodyPr wrap="square" lIns="36576" tIns="21945" rIns="36576" bIns="21945" anchor="ctr">
             <a:spAutoFit/>
           </a:bodyPr>
           <a:lstStyle/>
           <a:p>
             <a:pPr algn="l">
               <a:spcAft>
-                <a:spcPts val="100"/>
-              </a:spcAft>
-            </a:pPr>
-            <a:r>
-              <a:rPr sz="2000" b="1" i="0">
-                <a:solidFill>
-                  <a:srgbClr val="10204A"/>
+                <a:spcPts val="0"/>
+              </a:spcAft>
+            </a:pPr>
+            <a:r>
+              <a:rPr sz="1900" b="1" i="0">
+                <a:solidFill>
+                  <a:srgbClr val="455068"/>
                 </a:solidFill>
                 <a:latin typeface="Trebuchet MS"/>
               </a:rPr>
               <a:t>Model calls and cost</a:t>
             </a:r>
-            <a:endParaRPr sz="2000"/>
+            <a:endParaRPr sz="1900"/>
           </a:p>
           <a:p>
             <a:pPr algn="l">
@@ -15166,13 +15030,30 @@
               </a:spcAft>
             </a:pPr>
             <a:r>
+              <a:rPr sz="2100" b="1" i="0">
+                <a:solidFill>
+                  <a:srgbClr val="0B2272"/>
+                </a:solidFill>
+                <a:latin typeface="Trebuchet MS"/>
+              </a:rPr>
+              <a:t>2.3 calls · about $0.002</a:t>
+            </a:r>
+            <a:endParaRPr sz="2100"/>
+          </a:p>
+          <a:p>
+            <a:pPr algn="l">
+              <a:spcAft>
+                <a:spcPts val="0"/>
+              </a:spcAft>
+            </a:pPr>
+            <a:r>
               <a:rPr sz="1800" b="0" i="0">
                 <a:solidFill>
                   <a:srgbClr val="455068"/>
                 </a:solidFill>
                 <a:latin typeface="Trebuchet MS"/>
               </a:rPr>
-              <a:t>per question</a:t>
+              <a:t>per question; the price is an assumption</a:t>
             </a:r>
             <a:endParaRPr sz="1800"/>
           </a:p>
@@ -15180,76 +15061,14 @@
       </p:sp>
       <p:sp>
         <p:nvSpPr>
-          <p:cNvPr id="24" name="Rounded Rectangle 23"/>
+          <p:cNvPr id="20" name="Rounded Rectangle 19"/>
           <p:cNvSpPr/>
           <p:nvPr/>
         </p:nvSpPr>
         <p:spPr>
           <a:xfrm>
-            <a:off x="9262872" y="4530852"/>
-            <a:ext cx="2148840" cy="420624"/>
-          </a:xfrm>
-          <a:prstGeom prst="roundRect">
-            <a:avLst>
-              <a:gd name="adj" fmla="val 50000"/>
-            </a:avLst>
-          </a:prstGeom>
-          <a:solidFill>
-            <a:srgbClr val="EEF1F7"/>
-          </a:solidFill>
-          <a:ln w="12700">
-            <a:solidFill>
-              <a:srgbClr val="4A556E"/>
-            </a:solidFill>
-          </a:ln>
-          <a:effectLst/>
-        </p:spPr>
-        <p:style>
-          <a:lnRef idx="1">
-            <a:schemeClr val="accent1"/>
-          </a:lnRef>
-          <a:fillRef idx="3">
-            <a:schemeClr val="accent1"/>
-          </a:fillRef>
-          <a:effectRef idx="2">
-            <a:schemeClr val="accent1"/>
-          </a:effectRef>
-          <a:fontRef idx="minor">
-            <a:schemeClr val="lt1"/>
-          </a:fontRef>
-        </p:style>
-        <p:txBody>
-          <a:bodyPr wrap="square" lIns="27432" tIns="16459" rIns="27432" bIns="16459" rtlCol="0" anchor="ctr"/>
-          <a:lstStyle/>
-          <a:p>
-            <a:pPr algn="ctr">
-              <a:spcAft>
-                <a:spcPts val="0"/>
-              </a:spcAft>
-            </a:pPr>
-            <a:r>
-              <a:rPr sz="1800" b="1" i="0">
-                <a:solidFill>
-                  <a:srgbClr val="1E263A"/>
-                </a:solidFill>
-                <a:latin typeface="Trebuchet MS"/>
-              </a:rPr>
-              <a:t>to be measured</a:t>
-            </a:r>
-            <a:endParaRPr sz="1800"/>
-          </a:p>
-        </p:txBody>
-      </p:sp>
-      <p:sp>
-        <p:nvSpPr>
-          <p:cNvPr id="25" name="Rounded Rectangle 24"/>
-          <p:cNvSpPr/>
-          <p:nvPr/>
-        </p:nvSpPr>
-        <p:spPr>
-          <a:xfrm>
-            <a:off x="6208776" y="5404104"/>
-            <a:ext cx="5340096" cy="1106424"/>
+            <a:off x="6208776" y="5519928"/>
+            <a:ext cx="5340096" cy="990599"/>
           </a:xfrm>
           <a:prstGeom prst="roundRect">
             <a:avLst>
@@ -15293,14 +15112,14 @@
       </p:sp>
       <p:sp>
         <p:nvSpPr>
-          <p:cNvPr id="26" name="Rectangle 25"/>
+          <p:cNvPr id="21" name="Rectangle 20"/>
           <p:cNvSpPr/>
           <p:nvPr/>
         </p:nvSpPr>
         <p:spPr>
           <a:xfrm>
-            <a:off x="6208776" y="5513832"/>
-            <a:ext cx="73152" cy="886968"/>
+            <a:off x="6208776" y="5611368"/>
+            <a:ext cx="73152" cy="807720"/>
           </a:xfrm>
           <a:prstGeom prst="rect">
             <a:avLst/>
@@ -15338,14 +15157,14 @@
       </p:sp>
       <p:sp>
         <p:nvSpPr>
-          <p:cNvPr id="27" name="TextBox 26"/>
+          <p:cNvPr id="22" name="TextBox 21"/>
           <p:cNvSpPr txBox="1"/>
           <p:nvPr/>
         </p:nvSpPr>
         <p:spPr>
           <a:xfrm>
-            <a:off x="6391656" y="5404104"/>
-            <a:ext cx="2825496" cy="1106424"/>
+            <a:off x="6391656" y="5519928"/>
+            <a:ext cx="5065776" cy="990599"/>
           </a:xfrm>
           <a:prstGeom prst="rect">
             <a:avLst/>
@@ -15353,26 +15172,26 @@
           <a:noFill/>
         </p:spPr>
         <p:txBody>
-          <a:bodyPr wrap="square" lIns="54864" tIns="32918" rIns="54864" bIns="32918" anchor="ctr">
+          <a:bodyPr wrap="square" lIns="36576" tIns="21945" rIns="36576" bIns="21945" anchor="ctr">
             <a:spAutoFit/>
           </a:bodyPr>
           <a:lstStyle/>
           <a:p>
             <a:pPr algn="l">
               <a:spcAft>
-                <a:spcPts val="100"/>
-              </a:spcAft>
-            </a:pPr>
-            <a:r>
-              <a:rPr sz="2000" b="1" i="0">
-                <a:solidFill>
-                  <a:srgbClr val="10204A"/>
+                <a:spcPts val="0"/>
+              </a:spcAft>
+            </a:pPr>
+            <a:r>
+              <a:rPr sz="1900" b="1" i="0">
+                <a:solidFill>
+                  <a:srgbClr val="455068"/>
                 </a:solidFill>
                 <a:latin typeface="Trebuchet MS"/>
               </a:rPr>
               <a:t>Enrichment</a:t>
             </a:r>
-            <a:endParaRPr sz="2000"/>
+            <a:endParaRPr sz="1900"/>
           </a:p>
           <a:p>
             <a:pPr algn="l">
@@ -15381,75 +15200,30 @@
               </a:spcAft>
             </a:pPr>
             <a:r>
+              <a:rPr sz="2100" b="1" i="0">
+                <a:solidFill>
+                  <a:srgbClr val="0B2272"/>
+                </a:solidFill>
+                <a:latin typeface="Trebuchet MS"/>
+              </a:rPr>
+              <a:t>19 items per minute</a:t>
+            </a:r>
+            <a:endParaRPr sz="2100"/>
+          </a:p>
+          <a:p>
+            <a:pPr algn="l">
+              <a:spcAft>
+                <a:spcPts val="0"/>
+              </a:spcAft>
+            </a:pPr>
+            <a:r>
               <a:rPr sz="1800" b="0" i="0">
                 <a:solidFill>
                   <a:srgbClr val="455068"/>
                 </a:solidFill>
                 <a:latin typeface="Trebuchet MS"/>
               </a:rPr>
-              <a:t>items per minute · items per classification stage</a:t>
-            </a:r>
-            <a:endParaRPr sz="1800"/>
-          </a:p>
-        </p:txBody>
-      </p:sp>
-      <p:sp>
-        <p:nvSpPr>
-          <p:cNvPr id="28" name="Rounded Rectangle 27"/>
-          <p:cNvSpPr/>
-          <p:nvPr/>
-        </p:nvSpPr>
-        <p:spPr>
-          <a:xfrm>
-            <a:off x="9262872" y="5747004"/>
-            <a:ext cx="2148840" cy="420624"/>
-          </a:xfrm>
-          <a:prstGeom prst="roundRect">
-            <a:avLst>
-              <a:gd name="adj" fmla="val 50000"/>
-            </a:avLst>
-          </a:prstGeom>
-          <a:solidFill>
-            <a:srgbClr val="EEF1F7"/>
-          </a:solidFill>
-          <a:ln w="12700">
-            <a:solidFill>
-              <a:srgbClr val="4A556E"/>
-            </a:solidFill>
-          </a:ln>
-          <a:effectLst/>
-        </p:spPr>
-        <p:style>
-          <a:lnRef idx="1">
-            <a:schemeClr val="accent1"/>
-          </a:lnRef>
-          <a:fillRef idx="3">
-            <a:schemeClr val="accent1"/>
-          </a:fillRef>
-          <a:effectRef idx="2">
-            <a:schemeClr val="accent1"/>
-          </a:effectRef>
-          <a:fontRef idx="minor">
-            <a:schemeClr val="lt1"/>
-          </a:fontRef>
-        </p:style>
-        <p:txBody>
-          <a:bodyPr wrap="square" lIns="27432" tIns="16459" rIns="27432" bIns="16459" rtlCol="0" anchor="ctr"/>
-          <a:lstStyle/>
-          <a:p>
-            <a:pPr algn="ctr">
-              <a:spcAft>
-                <a:spcPts val="0"/>
-              </a:spcAft>
-            </a:pPr>
-            <a:r>
-              <a:rPr sz="1800" b="1" i="0">
-                <a:solidFill>
-                  <a:srgbClr val="1E263A"/>
-                </a:solidFill>
-                <a:latin typeface="Trebuchet MS"/>
-              </a:rPr>
-              <a:t>to be measured</a:t>
+              <a:t>71 % sorted by rules, 16 % by the model</a:t>
             </a:r>
             <a:endParaRPr sz="1800"/>
           </a:p>
@@ -16991,7 +16765,7 @@
                 </a:solidFill>
                 <a:latin typeface="Trebuchet MS"/>
               </a:rPr>
-              <a:t>End-to-end run and rehearsal</a:t>
+              <a:t>Evaluation, tests and thresholds measured; rehearsal</a:t>
             </a:r>
             <a:endParaRPr sz="1900"/>
           </a:p>
@@ -17943,7 +17717,7 @@
                 </a:solidFill>
                 <a:latin typeface="Trebuchet MS"/>
               </a:rPr>
-              <a:t>Sensitive pages and typed text never captured; the model never gets full emails</a:t>
+              <a:t>Sensitive pages and typed text never captured; the model never gets database rows</a:t>
             </a:r>
             <a:endParaRPr sz="1900"/>
           </a:p>
@@ -18904,6 +18678,30 @@
           </a:p>
         </p:txBody>
       </p:sp>
+      <p:pic>
+        <p:nvPicPr>
+          <p:cNvPr id="15" name="Picture 14" descr="image.png"/>
+          <p:cNvPicPr>
+            <a:picLocks noChangeAspect="1"/>
+          </p:cNvPicPr>
+          <p:nvPr/>
+        </p:nvPicPr>
+        <p:blipFill>
+          <a:blip r:embed="rId4"/>
+          <a:stretch>
+            <a:fillRect/>
+          </a:stretch>
+        </p:blipFill>
+        <p:spPr>
+          <a:xfrm>
+            <a:off x="817029" y="1874519"/>
+            <a:ext cx="10554893" cy="4636007"/>
+          </a:xfrm>
+          <a:prstGeom prst="rect">
+            <a:avLst/>
+          </a:prstGeom>
+        </p:spPr>
+      </p:pic>
     </p:spTree>
   </p:cSld>
   <p:clrMapOvr>
@@ -18975,6 +18773,37 @@
           </a:p>
         </p:txBody>
       </p:sp>
+      <p:sp>
+        <p:nvSpPr>
+          <p:cNvPr id="5" name="TextBox 4"/>
+          <p:cNvSpPr txBox="1"/>
+          <p:nvPr/>
+        </p:nvSpPr>
+        <p:spPr>
+          <a:xfrm>
+            <a:off x="2194560" y="4338442"/>
+            <a:ext cx="7772400" cy="457971"/>
+          </a:xfrm>
+          <a:prstGeom prst="rect">
+            <a:avLst/>
+          </a:prstGeom>
+          <a:noFill/>
+        </p:spPr>
+        <p:txBody>
+          <a:bodyPr wrap="square" lIns="73152" tIns="43891" rIns="73152" bIns="43891" anchor="ctr">
+            <a:spAutoFit/>
+          </a:bodyPr>
+          <a:lstStyle/>
+          <a:p>
+            <a:pPr algn="ctr">
+              <a:spcAft>
+                <a:spcPts val="0"/>
+              </a:spcAft>
+            </a:pPr>
+            <a:endParaRPr sz="2400" dirty="0"/>
+          </a:p>
+        </p:txBody>
+      </p:sp>
     </p:spTree>
   </p:cSld>
   <p:clrMapOvr>
@@ -20435,7 +20264,7 @@
                 </a:solidFill>
                 <a:latin typeface="Trebuchet MS"/>
               </a:rPr>
-              <a:t>Storage and processing run on your laptop. Only your question and short snippets go to the language model, never full emails.</a:t>
+              <a:t>Storage and processing run on your laptop. The language model gets your question and limited excerpts of the best matches, never database rows.</a:t>
             </a:r>
             <a:endParaRPr sz="1900"/>
           </a:p>
@@ -23619,7 +23448,7 @@
                 </a:solidFill>
                 <a:latin typeface="Trebuchet MS"/>
               </a:rPr>
-              <a:t>your question and short snippets, never full emails</a:t>
+              <a:t>your question and limited excerpts, never database rows</a:t>
             </a:r>
             <a:endParaRPr sz="1900"/>
           </a:p>
@@ -26666,7 +26495,7 @@
                 </a:solidFill>
                 <a:latin typeface="Trebuchet MS"/>
               </a:rPr>
-              <a:t>LangGraph + LangChain · OpenAI gpt-5.6-luna · PostgreSQL full-text search · FAISS · local cross-encoder · FastAPI · React · MCP</a:t>
+              <a:t>LangGraph + LangChain · OpenAI gpt-6-luna · PostgreSQL full-text search · FAISS · local cross-encoder · FastAPI · React · MCP</a:t>
             </a:r>
             <a:endParaRPr sz="1800"/>
           </a:p>
@@ -28016,7 +27845,7 @@
                 </a:solidFill>
                 <a:latin typeface="Trebuchet MS"/>
               </a:rPr>
-              <a:t>2 – 6</a:t>
+              <a:t>2.3 mean</a:t>
             </a:r>
             <a:endParaRPr sz="2400"/>
           </a:p>
@@ -28033,7 +27862,7 @@
                 </a:solidFill>
                 <a:latin typeface="Trebuchet MS"/>
               </a:rPr>
-              <a:t>model calls per question</a:t>
+              <a:t>model calls per question (2 – 6)</a:t>
             </a:r>
             <a:endParaRPr sz="1800"/>
           </a:p>

</xml_diff>